<commit_message>
- fixed battery model - updated ppt slides
</commit_message>
<xml_diff>
--- a/docs/model_slides/all_models.pptx
+++ b/docs/model_slides/all_models.pptx
@@ -3465,7 +3465,7 @@
                   <a:srgbClr val="52514E"/>
                 </a:solidFill>
               </a:rPr>
-              <a:t>Universe-gate bug found &amp; fixed (2026-09-11) — still no score or confusion matrix, for a different reason now</a:t>
+              <a:t>Evaluation is blocked before any score or confusion matrix exists</a:t>
             </a:r>
           </a:p>
         </p:txBody>
@@ -3532,16 +3532,6 @@
                   <a:srgbClr val="11111A"/>
                 </a:solidFill>
               </a:rPr>
-              <a:t>•  Fixed: the gate's "measured" test required a positive export reading, so it treated a working register that reads exactly zero every day the same as a missing meter — but a greedy self-consumption / feed-in-limited battery is expected to leave no export at all. All 14 rejected households have a confirmed-working register (100+ daily readings, always 0.0 kWh). Admitting register presence instead of positive readings takes retention from 208/222 (93.7%) to 222/222 (100%), label-blind throughout</a:t>
-            </a:r>
-          </a:p>
-          <a:p>
-            <a:r>
-              <a:rPr sz="950">
-                <a:solidFill>
-                  <a:srgbClr val="11111A"/>
-                </a:solidFill>
-              </a:rPr>
               <a:t>•  Design: reuses the PV pipeline's I/O + PU learner (Elkan–Noto); contrast is battery vs PV-without-battery, not vs the general population — 96% of GIGI battery households also have PV, so a population-wide model would just relearn “has PV”</a:t>
             </a:r>
           </a:p>
@@ -3562,7 +3552,7 @@
                   <a:srgbClr val="11111A"/>
                 </a:solidFill>
               </a:rPr>
-              <a:t>•  82 GIGI “no battery” households remain a held-out audit set, never used as training negatives</a:t>
+              <a:t>•  82 GIGI “no battery” households are a held-out audit set, never used as training negatives</a:t>
             </a:r>
           </a:p>
           <a:p>
@@ -3572,7 +3562,17 @@
                   <a:srgbClr val="11111A"/>
                 </a:solidFill>
               </a:rPr>
-              <a:t>•  Not yet done: the full streaming pass (Step 3, 77 GB) hasn't run, and aggregation/train/evaluate/score (Steps 4–7) aren't implemented — the gate no longer blocks the pipeline, but nothing downstream of it has been built or run</a:t>
+              <a:t>•  Universe gate (label-blind) requires ≥95% of known-battery households to be admissible to the PV-likely universe; measured export gives 93.7% (208/222) — pipeline halted per spec rather than weakening the gate or fabricating a result</a:t>
+            </a:r>
+          </a:p>
+          <a:p>
+            <a:r>
+              <a:rPr sz="950">
+                <a:solidFill>
+                  <a:srgbClr val="11111A"/>
+                </a:solidFill>
+              </a:rPr>
+              <a:t>•  Re-checked 2026-09-11: the 14 missing households are unobservable, not mismeasured — they never export, and score pv_probability 0.012–0.482 on the import side too. Relaxing the rule to "has an export register" is not a fix: all 93k meters do, so it admits everyone and the model relearns “has PV”. Unblocking needs a plan decision, not a code change</a:t>
             </a:r>
           </a:p>
         </p:txBody>

</xml_diff>